<commit_message>
Use Types of Mobile Marketing wording and American spelling
Co-Authored-By: Claude Opus 5.5 <noreply@anthropic.com>
Claude-Session: https://claude.ai/code/session_01CsSUN8PLn8omZWE5zj21pc
</commit_message>
<xml_diff>
--- a/digital-marketing-tools.pptx
+++ b/digital-marketing-tools.pptx
@@ -510,7 +510,7 @@
           <a:p/>
           <a:p>
             <a:r>
-              <a:t>Search ads: triggered by the keywords people type and labelled "Sponsored". Use pay-per-click (PPC), so the business only pays when someone clicks. They reach people who are already looking for the product.</a:t>
+              <a:t>Search ads: triggered by the keywords people type and labeled "Sponsored". Use pay-per-click (PPC), so the business only pays when someone clicks. They reach people who are already looking for the product.</a:t>
             </a:r>
           </a:p>
           <a:p/>
@@ -3718,7 +3718,7 @@
                 </a:solidFill>
                 <a:latin typeface="Calibri"/>
               </a:rPr>
-              <a:t>Digital Marketing Tools (1/2)</a:t>
+              <a:t>Types of Mobile Marketing (1/2)</a:t>
             </a:r>
           </a:p>
         </p:txBody>
@@ -3947,7 +3947,7 @@
                 </a:solidFill>
                 <a:latin typeface="Calibri"/>
               </a:rPr>
-              <a:t>A "30% Off" banner on a news website.</a:t>
+              <a:t>A banner showing a discount.</a:t>
             </a:r>
           </a:p>
         </p:txBody>
@@ -4176,7 +4176,7 @@
                 </a:solidFill>
                 <a:latin typeface="Calibri"/>
               </a:rPr>
-              <a:t>A sponsored ramen restaurant at the top of Google.</a:t>
+              <a:t>A restaurant ad on Google.</a:t>
             </a:r>
           </a:p>
         </p:txBody>
@@ -4405,7 +4405,7 @@
                 </a:solidFill>
                 <a:latin typeface="Calibri"/>
               </a:rPr>
-              <a:t>A short YouTube ad before a video.</a:t>
+              <a:t>A YouTube advertisement.</a:t>
             </a:r>
           </a:p>
         </p:txBody>
@@ -4634,7 +4634,7 @@
                 </a:solidFill>
                 <a:latin typeface="Calibri"/>
               </a:rPr>
-              <a:t>A discount code sent by SMS.</a:t>
+              <a:t>A discount code sent by text.</a:t>
             </a:r>
           </a:p>
         </p:txBody>
@@ -4695,7 +4695,7 @@
                 </a:solidFill>
                 <a:latin typeface="Calibri"/>
               </a:rPr>
-              <a:t>Digital Marketing Tools (2/2)</a:t>
+              <a:t>Types of Mobile Marketing (2/2)</a:t>
             </a:r>
           </a:p>
         </p:txBody>
@@ -4924,14 +4924,14 @@
                 </a:solidFill>
                 <a:latin typeface="Calibri"/>
               </a:rPr>
-              <a:t>Watching an ad in a game for an extra life.</a:t>
-            </a:r>
-          </a:p>
-        </p:txBody>
-      </p:sp>
-      <p:sp>
-        <p:nvSpPr>
-          <p:cNvPr id="10" name="QR Codes, Digital Watermarks and 2D Barcodes card"/>
+              <a:t>An ad appearing in a mobile game.</a:t>
+            </a:r>
+          </a:p>
+        </p:txBody>
+      </p:sp>
+      <p:sp>
+        <p:nvSpPr>
+          <p:cNvPr id="10" name="QR Codes, Digital Watermarks, and 2D Barcodes card"/>
           <p:cNvSpPr/>
           <p:nvPr/>
         </p:nvSpPr>
@@ -5015,7 +5015,7 @@
       </p:pic>
       <p:sp>
         <p:nvSpPr>
-          <p:cNvPr id="13" name="QR Codes, Digital Watermarks and 2D Barcodes name"/>
+          <p:cNvPr id="13" name="QR Codes, Digital Watermarks, and 2D Barcodes name"/>
           <p:cNvSpPr txBox="1"/>
           <p:nvPr/>
         </p:nvSpPr>
@@ -5043,14 +5043,14 @@
                 </a:solidFill>
                 <a:latin typeface="Calibri"/>
               </a:rPr>
-              <a:t>QR Codes, Digital Watermarks and 2D Barcodes</a:t>
-            </a:r>
-          </a:p>
-        </p:txBody>
-      </p:sp>
-      <p:sp>
-        <p:nvSpPr>
-          <p:cNvPr id="14" name="QR Codes, Digital Watermarks and 2D Barcodes definition"/>
+              <a:t>QR Codes, Digital Watermarks, and 2D Barcodes</a:t>
+            </a:r>
+          </a:p>
+        </p:txBody>
+      </p:sp>
+      <p:sp>
+        <p:nvSpPr>
+          <p:cNvPr id="14" name="QR Codes, Digital Watermarks, and 2D Barcodes definition"/>
           <p:cNvSpPr txBox="1"/>
           <p:nvPr/>
         </p:nvSpPr>
@@ -5078,7 +5078,7 @@
                 </a:solidFill>
                 <a:latin typeface="Calibri"/>
               </a:rPr>
-              <a:t>Technologies that connect users to digital information.</a:t>
+              <a:t>Technologies connecting users to digital information.</a:t>
             </a:r>
           </a:p>
         </p:txBody>
@@ -5382,7 +5382,7 @@
                 </a:solidFill>
                 <a:latin typeface="Calibri"/>
               </a:rPr>
-              <a:t>A café sending offers to people nearby.</a:t>
+              <a:t>A café promotes offers to people nearby.</a:t>
             </a:r>
           </a:p>
         </p:txBody>
@@ -5443,7 +5443,7 @@
                 </a:solidFill>
                 <a:latin typeface="Calibri"/>
               </a:rPr>
-              <a:t>Search Engine Optimisation (SEO)</a:t>
+              <a:t>Search Engine Optimization (SEO)</a:t>
             </a:r>
           </a:p>
         </p:txBody>
@@ -5564,7 +5564,7 @@
                 </a:solidFill>
                 <a:latin typeface="Calibri"/>
               </a:rPr>
-              <a:t>A shoe store appearing on Google's first page for "running shoes"</a:t>
+              <a:t>A shoe store optimizes its website so customers can find it when searching for running shoes on Google</a:t>
             </a:r>
           </a:p>
         </p:txBody>
@@ -5984,7 +5984,7 @@
                 </a:solidFill>
                 <a:latin typeface="Calibri"/>
               </a:rPr>
-              <a:t>stridestore.com.au</a:t>
+              <a:t>stridestore.com</a:t>
             </a:r>
           </a:p>
         </p:txBody>
@@ -6184,7 +6184,7 @@
                 </a:solidFill>
                 <a:latin typeface="Calibri"/>
               </a:rPr>
-              <a:t>stridestore.com.au</a:t>
+              <a:t>stridestore.com</a:t>
             </a:r>
           </a:p>
         </p:txBody>

</xml_diff>

<commit_message>
Keep the SEO slide focused on SEO only
Co-Authored-By: Claude Opus 5.5 <noreply@anthropic.com>
Claude-Session: https://claude.ai/code/session_01CsSUN8PLn8omZWE5zj21pc
</commit_message>
<xml_diff>
--- a/digital-marketing-tools.pptx
+++ b/digital-marketing-tools.pptx
@@ -674,7 +674,7 @@
           <a:lstStyle/>
           <a:p>
             <a:r>
-              <a:t>SEO improves a website so it ranks higher in organic search results. Key elements are using relevant keywords in titles, headings and content, publishing useful content, making the site fast and mobile-friendly, and getting backlinks from trusted websites. Compared with search ads, SEO is free and long-term but takes time, while search ads are paid and give instant results. For example, a shoe store could write a blog post like "Best Running Shoes for Beginners" and use "running shoes" in its page titles so it shows up when people search for running shoes.</a:t>
+              <a:t>SEO improves a website so it ranks higher in organic search results. Key elements are using relevant keywords in titles, headings and content, publishing useful content, making the site fast and mobile-friendly, and getting backlinks from trusted websites. SEO does not cost money for ads and its results last a long time, but it takes time to work. For example, a shoe store could write a blog post like "Best Running Shoes for Beginners" and use "running shoes" in its page titles so it shows up when people search for running shoes.</a:t>
             </a:r>
           </a:p>
         </p:txBody>
@@ -5506,7 +5506,7 @@
                 </a:solidFill>
                 <a:latin typeface="Calibri"/>
               </a:rPr>
-              <a:t>Focuses on organic (unpaid) results, unlike search ads</a:t>
+              <a:t>Helps a website rank higher in organic (unpaid) results</a:t>
             </a:r>
           </a:p>
           <a:p>
@@ -5723,13 +5723,213 @@
       </p:pic>
       <p:sp>
         <p:nvSpPr>
-          <p:cNvPr id="9" name="Search ad (paid) result"/>
+          <p:cNvPr id="9" name="stridestore.com result"/>
           <p:cNvSpPr/>
           <p:nvPr/>
         </p:nvSpPr>
         <p:spPr>
           <a:xfrm>
             <a:off x="6903720" y="2468880"/>
+            <a:ext cx="4419295" cy="1097280"/>
+          </a:xfrm>
+          <a:prstGeom prst="roundRect">
+            <a:avLst>
+              <a:gd name="adj" fmla="val 12500"/>
+            </a:avLst>
+          </a:prstGeom>
+          <a:solidFill>
+            <a:srgbClr val="FFFFFF"/>
+          </a:solidFill>
+          <a:ln w="12700">
+            <a:solidFill>
+              <a:srgbClr val="6D28D9"/>
+            </a:solidFill>
+          </a:ln>
+        </p:spPr>
+        <p:txBody>
+          <a:bodyPr rtlCol="0" anchor="ctr"/>
+          <a:lstStyle/>
+          <a:p>
+            <a:pPr algn="ctr"/>
+          </a:p>
+        </p:txBody>
+      </p:sp>
+      <p:sp>
+        <p:nvSpPr>
+          <p:cNvPr id="10" name="Result source"/>
+          <p:cNvSpPr txBox="1"/>
+          <p:nvPr/>
+        </p:nvSpPr>
+        <p:spPr>
+          <a:xfrm>
+            <a:off x="7132320" y="2606040"/>
+            <a:ext cx="2041855" cy="274320"/>
+          </a:xfrm>
+          <a:prstGeom prst="rect">
+            <a:avLst/>
+          </a:prstGeom>
+          <a:noFill/>
+        </p:spPr>
+        <p:txBody>
+          <a:bodyPr wrap="square" anchor="t" lIns="0" rIns="0" tIns="0" bIns="0">
+            <a:noAutofit/>
+          </a:bodyPr>
+          <a:lstStyle/>
+          <a:p>
+            <a:pPr algn="l"/>
+            <a:r>
+              <a:rPr sz="1200" b="0" i="0">
+                <a:solidFill>
+                  <a:srgbClr val="6B7280"/>
+                </a:solidFill>
+                <a:latin typeface="Calibri"/>
+              </a:rPr>
+              <a:t>stridestore.com</a:t>
+            </a:r>
+          </a:p>
+        </p:txBody>
+      </p:sp>
+      <p:sp>
+        <p:nvSpPr>
+          <p:cNvPr id="11" name="Top result chip"/>
+          <p:cNvSpPr/>
+          <p:nvPr/>
+        </p:nvSpPr>
+        <p:spPr>
+          <a:xfrm>
+            <a:off x="9219895" y="2606040"/>
+            <a:ext cx="1920240" cy="292608"/>
+          </a:xfrm>
+          <a:prstGeom prst="roundRect">
+            <a:avLst>
+              <a:gd name="adj" fmla="val 50000"/>
+            </a:avLst>
+          </a:prstGeom>
+          <a:solidFill>
+            <a:srgbClr val="6D28D9"/>
+          </a:solidFill>
+          <a:ln>
+            <a:noFill/>
+          </a:ln>
+        </p:spPr>
+        <p:txBody>
+          <a:bodyPr rtlCol="0" anchor="ctr"/>
+          <a:lstStyle/>
+          <a:p>
+            <a:pPr algn="ctr"/>
+          </a:p>
+        </p:txBody>
+      </p:sp>
+      <p:sp>
+        <p:nvSpPr>
+          <p:cNvPr id="12" name="Top result label"/>
+          <p:cNvSpPr txBox="1"/>
+          <p:nvPr/>
+        </p:nvSpPr>
+        <p:spPr>
+          <a:xfrm>
+            <a:off x="9219895" y="2606040"/>
+            <a:ext cx="1920240" cy="292608"/>
+          </a:xfrm>
+          <a:prstGeom prst="rect">
+            <a:avLst/>
+          </a:prstGeom>
+          <a:noFill/>
+        </p:spPr>
+        <p:txBody>
+          <a:bodyPr wrap="square" anchor="ctr" lIns="0" rIns="0" tIns="0" bIns="0">
+            <a:noAutofit/>
+          </a:bodyPr>
+          <a:lstStyle/>
+          <a:p>
+            <a:pPr algn="ctr"/>
+            <a:r>
+              <a:rPr sz="1200" b="1" i="0">
+                <a:solidFill>
+                  <a:srgbClr val="FFFFFF"/>
+                </a:solidFill>
+                <a:latin typeface="Calibri"/>
+              </a:rPr>
+              <a:t>#1 thanks to SEO</a:t>
+            </a:r>
+          </a:p>
+        </p:txBody>
+      </p:sp>
+      <p:sp>
+        <p:nvSpPr>
+          <p:cNvPr id="13" name="Result headline"/>
+          <p:cNvSpPr txBox="1"/>
+          <p:nvPr/>
+        </p:nvSpPr>
+        <p:spPr>
+          <a:xfrm>
+            <a:off x="7132320" y="2944368"/>
+            <a:ext cx="3962095" cy="320040"/>
+          </a:xfrm>
+          <a:prstGeom prst="rect">
+            <a:avLst/>
+          </a:prstGeom>
+          <a:noFill/>
+        </p:spPr>
+        <p:txBody>
+          <a:bodyPr wrap="square" anchor="t" lIns="0" rIns="0" tIns="0" bIns="0">
+            <a:noAutofit/>
+          </a:bodyPr>
+          <a:lstStyle/>
+          <a:p>
+            <a:pPr algn="l"/>
+            <a:r>
+              <a:rPr sz="1600" b="1" i="0">
+                <a:solidFill>
+                  <a:srgbClr val="6D28D9"/>
+                </a:solidFill>
+                <a:latin typeface="Calibri"/>
+              </a:rPr>
+              <a:t>Best Running Shoes for Beginners</a:t>
+            </a:r>
+          </a:p>
+        </p:txBody>
+      </p:sp>
+      <p:sp>
+        <p:nvSpPr>
+          <p:cNvPr id="14" name="Result snippet"/>
+          <p:cNvSpPr/>
+          <p:nvPr/>
+        </p:nvSpPr>
+        <p:spPr>
+          <a:xfrm>
+            <a:off x="7132320" y="3319272"/>
+            <a:ext cx="2872541" cy="91440"/>
+          </a:xfrm>
+          <a:prstGeom prst="roundRect">
+            <a:avLst>
+              <a:gd name="adj" fmla="val 50000"/>
+            </a:avLst>
+          </a:prstGeom>
+          <a:solidFill>
+            <a:srgbClr val="E5E7EB"/>
+          </a:solidFill>
+          <a:ln>
+            <a:noFill/>
+          </a:ln>
+        </p:spPr>
+        <p:txBody>
+          <a:bodyPr rtlCol="0" anchor="ctr"/>
+          <a:lstStyle/>
+          <a:p>
+            <a:pPr algn="ctr"/>
+          </a:p>
+        </p:txBody>
+      </p:sp>
+      <p:sp>
+        <p:nvSpPr>
+          <p:cNvPr id="15" name="shoereviews.com result"/>
+          <p:cNvSpPr/>
+          <p:nvPr/>
+        </p:nvSpPr>
+        <p:spPr>
+          <a:xfrm>
+            <a:off x="6903720" y="3749039"/>
             <a:ext cx="4419295" cy="1097280"/>
           </a:xfrm>
           <a:prstGeom prst="roundRect">
@@ -5756,13 +5956,13 @@
       </p:sp>
       <p:sp>
         <p:nvSpPr>
-          <p:cNvPr id="10" name="Result source"/>
+          <p:cNvPr id="16" name="Result source"/>
           <p:cNvSpPr txBox="1"/>
           <p:nvPr/>
         </p:nvSpPr>
         <p:spPr>
           <a:xfrm>
-            <a:off x="7132320" y="2606040"/>
+            <a:off x="7132320" y="3886200"/>
             <a:ext cx="2041855" cy="274320"/>
           </a:xfrm>
           <a:prstGeom prst="rect">
@@ -5778,27 +5978,62 @@
           <a:p>
             <a:pPr algn="l"/>
             <a:r>
-              <a:rPr sz="1200" b="1" i="0">
+              <a:rPr sz="1200" b="0" i="0">
                 <a:solidFill>
                   <a:srgbClr val="6B7280"/>
                 </a:solidFill>
                 <a:latin typeface="Calibri"/>
               </a:rPr>
-              <a:t>Sponsored</a:t>
-            </a:r>
-          </a:p>
-        </p:txBody>
-      </p:sp>
-      <p:sp>
-        <p:nvSpPr>
-          <p:cNvPr id="11" name="Search ad (paid) chip"/>
+              <a:t>shoereviews.com</a:t>
+            </a:r>
+          </a:p>
+        </p:txBody>
+      </p:sp>
+      <p:sp>
+        <p:nvSpPr>
+          <p:cNvPr id="17" name="Result headline"/>
+          <p:cNvSpPr txBox="1"/>
+          <p:nvPr/>
+        </p:nvSpPr>
+        <p:spPr>
+          <a:xfrm>
+            <a:off x="7132320" y="4224527"/>
+            <a:ext cx="3962095" cy="320040"/>
+          </a:xfrm>
+          <a:prstGeom prst="rect">
+            <a:avLst/>
+          </a:prstGeom>
+          <a:noFill/>
+        </p:spPr>
+        <p:txBody>
+          <a:bodyPr wrap="square" anchor="t" lIns="0" rIns="0" tIns="0" bIns="0">
+            <a:noAutofit/>
+          </a:bodyPr>
+          <a:lstStyle/>
+          <a:p>
+            <a:pPr algn="l"/>
+            <a:r>
+              <a:rPr sz="1600" b="1" i="0">
+                <a:solidFill>
+                  <a:srgbClr val="1F1B2E"/>
+                </a:solidFill>
+                <a:latin typeface="Calibri"/>
+              </a:rPr>
+              <a:t>Top 10 Running Shoes This Year</a:t>
+            </a:r>
+          </a:p>
+        </p:txBody>
+      </p:sp>
+      <p:sp>
+        <p:nvSpPr>
+          <p:cNvPr id="18" name="Result snippet"/>
           <p:cNvSpPr/>
           <p:nvPr/>
         </p:nvSpPr>
         <p:spPr>
           <a:xfrm>
-            <a:off x="9219895" y="2606040"/>
-            <a:ext cx="1920240" cy="292608"/>
+            <a:off x="7132320" y="4599431"/>
+            <a:ext cx="2872541" cy="91440"/>
           </a:xfrm>
           <a:prstGeom prst="roundRect">
             <a:avLst>
@@ -5822,14 +6057,47 @@
       </p:sp>
       <p:sp>
         <p:nvSpPr>
-          <p:cNvPr id="12" name="Search ad (paid) label"/>
+          <p:cNvPr id="19" name="footwearhub.com result"/>
+          <p:cNvSpPr/>
+          <p:nvPr/>
+        </p:nvSpPr>
+        <p:spPr>
+          <a:xfrm>
+            <a:off x="6903720" y="5029200"/>
+            <a:ext cx="4419295" cy="1097280"/>
+          </a:xfrm>
+          <a:prstGeom prst="roundRect">
+            <a:avLst>
+              <a:gd name="adj" fmla="val 12500"/>
+            </a:avLst>
+          </a:prstGeom>
+          <a:solidFill>
+            <a:srgbClr val="FFFFFF"/>
+          </a:solidFill>
+          <a:ln w="12700">
+            <a:solidFill>
+              <a:srgbClr val="E5E7EB"/>
+            </a:solidFill>
+          </a:ln>
+        </p:spPr>
+        <p:txBody>
+          <a:bodyPr rtlCol="0" anchor="ctr"/>
+          <a:lstStyle/>
+          <a:p>
+            <a:pPr algn="ctr"/>
+          </a:p>
+        </p:txBody>
+      </p:sp>
+      <p:sp>
+        <p:nvSpPr>
+          <p:cNvPr id="20" name="Result source"/>
           <p:cNvSpPr txBox="1"/>
           <p:nvPr/>
         </p:nvSpPr>
         <p:spPr>
           <a:xfrm>
-            <a:off x="9219895" y="2606040"/>
-            <a:ext cx="1920240" cy="292608"/>
+            <a:off x="7132320" y="5166360"/>
+            <a:ext cx="2041855" cy="274320"/>
           </a:xfrm>
           <a:prstGeom prst="rect">
             <a:avLst/>
@@ -5837,33 +6105,33 @@
           <a:noFill/>
         </p:spPr>
         <p:txBody>
-          <a:bodyPr wrap="square" anchor="ctr" lIns="0" rIns="0" tIns="0" bIns="0">
+          <a:bodyPr wrap="square" anchor="t" lIns="0" rIns="0" tIns="0" bIns="0">
             <a:noAutofit/>
           </a:bodyPr>
           <a:lstStyle/>
           <a:p>
-            <a:pPr algn="ctr"/>
-            <a:r>
-              <a:rPr sz="1200" b="1" i="0">
+            <a:pPr algn="l"/>
+            <a:r>
+              <a:rPr sz="1200" b="0" i="0">
                 <a:solidFill>
-                  <a:srgbClr val="374151"/>
+                  <a:srgbClr val="6B7280"/>
                 </a:solidFill>
                 <a:latin typeface="Calibri"/>
               </a:rPr>
-              <a:t>Search ad (paid)</a:t>
-            </a:r>
-          </a:p>
-        </p:txBody>
-      </p:sp>
-      <p:sp>
-        <p:nvSpPr>
-          <p:cNvPr id="13" name="Result headline"/>
+              <a:t>footwearhub.com</a:t>
+            </a:r>
+          </a:p>
+        </p:txBody>
+      </p:sp>
+      <p:sp>
+        <p:nvSpPr>
+          <p:cNvPr id="21" name="Result headline"/>
           <p:cNvSpPr txBox="1"/>
           <p:nvPr/>
         </p:nvSpPr>
         <p:spPr>
           <a:xfrm>
-            <a:off x="7132320" y="2944368"/>
+            <a:off x="7132320" y="5504688"/>
             <a:ext cx="3962095" cy="320040"/>
           </a:xfrm>
           <a:prstGeom prst="rect">
@@ -5885,414 +6153,14 @@
                 </a:solidFill>
                 <a:latin typeface="Calibri"/>
               </a:rPr>
-              <a:t>Sprint Sports: 20% off running shoes</a:t>
-            </a:r>
-          </a:p>
-        </p:txBody>
-      </p:sp>
-      <p:sp>
-        <p:nvSpPr>
-          <p:cNvPr id="14" name="Result snippet"/>
-          <p:cNvSpPr/>
-          <p:nvPr/>
-        </p:nvSpPr>
-        <p:spPr>
-          <a:xfrm>
-            <a:off x="7132320" y="3319272"/>
-            <a:ext cx="2872541" cy="91440"/>
-          </a:xfrm>
-          <a:prstGeom prst="roundRect">
-            <a:avLst>
-              <a:gd name="adj" fmla="val 50000"/>
-            </a:avLst>
-          </a:prstGeom>
-          <a:solidFill>
-            <a:srgbClr val="E5E7EB"/>
-          </a:solidFill>
-          <a:ln>
-            <a:noFill/>
-          </a:ln>
-        </p:spPr>
-        <p:txBody>
-          <a:bodyPr rtlCol="0" anchor="ctr"/>
-          <a:lstStyle/>
-          <a:p>
-            <a:pPr algn="ctr"/>
-          </a:p>
-        </p:txBody>
-      </p:sp>
-      <p:sp>
-        <p:nvSpPr>
-          <p:cNvPr id="15" name="Organic result (SEO) result"/>
-          <p:cNvSpPr/>
-          <p:nvPr/>
-        </p:nvSpPr>
-        <p:spPr>
-          <a:xfrm>
-            <a:off x="6903720" y="3749039"/>
-            <a:ext cx="4419295" cy="1097280"/>
-          </a:xfrm>
-          <a:prstGeom prst="roundRect">
-            <a:avLst>
-              <a:gd name="adj" fmla="val 12500"/>
-            </a:avLst>
-          </a:prstGeom>
-          <a:solidFill>
-            <a:srgbClr val="FFFFFF"/>
-          </a:solidFill>
-          <a:ln w="12700">
-            <a:solidFill>
-              <a:srgbClr val="6D28D9"/>
-            </a:solidFill>
-          </a:ln>
-        </p:spPr>
-        <p:txBody>
-          <a:bodyPr rtlCol="0" anchor="ctr"/>
-          <a:lstStyle/>
-          <a:p>
-            <a:pPr algn="ctr"/>
-          </a:p>
-        </p:txBody>
-      </p:sp>
-      <p:sp>
-        <p:nvSpPr>
-          <p:cNvPr id="16" name="Result source"/>
-          <p:cNvSpPr txBox="1"/>
-          <p:nvPr/>
-        </p:nvSpPr>
-        <p:spPr>
-          <a:xfrm>
-            <a:off x="7132320" y="3886200"/>
-            <a:ext cx="2041855" cy="274320"/>
-          </a:xfrm>
-          <a:prstGeom prst="rect">
-            <a:avLst/>
-          </a:prstGeom>
-          <a:noFill/>
-        </p:spPr>
-        <p:txBody>
-          <a:bodyPr wrap="square" anchor="t" lIns="0" rIns="0" tIns="0" bIns="0">
-            <a:noAutofit/>
-          </a:bodyPr>
-          <a:lstStyle/>
-          <a:p>
-            <a:pPr algn="l"/>
-            <a:r>
-              <a:rPr sz="1200" b="0" i="0">
-                <a:solidFill>
-                  <a:srgbClr val="6B7280"/>
-                </a:solidFill>
-                <a:latin typeface="Calibri"/>
-              </a:rPr>
-              <a:t>stridestore.com</a:t>
-            </a:r>
-          </a:p>
-        </p:txBody>
-      </p:sp>
-      <p:sp>
-        <p:nvSpPr>
-          <p:cNvPr id="17" name="Organic result (SEO) chip"/>
-          <p:cNvSpPr/>
-          <p:nvPr/>
-        </p:nvSpPr>
-        <p:spPr>
-          <a:xfrm>
-            <a:off x="9219895" y="3886200"/>
-            <a:ext cx="1920240" cy="292608"/>
-          </a:xfrm>
-          <a:prstGeom prst="roundRect">
-            <a:avLst>
-              <a:gd name="adj" fmla="val 50000"/>
-            </a:avLst>
-          </a:prstGeom>
-          <a:solidFill>
-            <a:srgbClr val="6D28D9"/>
-          </a:solidFill>
-          <a:ln>
-            <a:noFill/>
-          </a:ln>
-        </p:spPr>
-        <p:txBody>
-          <a:bodyPr rtlCol="0" anchor="ctr"/>
-          <a:lstStyle/>
-          <a:p>
-            <a:pPr algn="ctr"/>
-          </a:p>
-        </p:txBody>
-      </p:sp>
-      <p:sp>
-        <p:nvSpPr>
-          <p:cNvPr id="18" name="Organic result (SEO) label"/>
-          <p:cNvSpPr txBox="1"/>
-          <p:nvPr/>
-        </p:nvSpPr>
-        <p:spPr>
-          <a:xfrm>
-            <a:off x="9219895" y="3886200"/>
-            <a:ext cx="1920240" cy="292608"/>
-          </a:xfrm>
-          <a:prstGeom prst="rect">
-            <a:avLst/>
-          </a:prstGeom>
-          <a:noFill/>
-        </p:spPr>
-        <p:txBody>
-          <a:bodyPr wrap="square" anchor="ctr" lIns="0" rIns="0" tIns="0" bIns="0">
-            <a:noAutofit/>
-          </a:bodyPr>
-          <a:lstStyle/>
-          <a:p>
-            <a:pPr algn="ctr"/>
-            <a:r>
-              <a:rPr sz="1200" b="1" i="0">
-                <a:solidFill>
-                  <a:srgbClr val="FFFFFF"/>
-                </a:solidFill>
-                <a:latin typeface="Calibri"/>
-              </a:rPr>
-              <a:t>Organic result (SEO)</a:t>
-            </a:r>
-          </a:p>
-        </p:txBody>
-      </p:sp>
-      <p:sp>
-        <p:nvSpPr>
-          <p:cNvPr id="19" name="Result headline"/>
-          <p:cNvSpPr txBox="1"/>
-          <p:nvPr/>
-        </p:nvSpPr>
-        <p:spPr>
-          <a:xfrm>
-            <a:off x="7132320" y="4224527"/>
-            <a:ext cx="3962095" cy="320040"/>
-          </a:xfrm>
-          <a:prstGeom prst="rect">
-            <a:avLst/>
-          </a:prstGeom>
-          <a:noFill/>
-        </p:spPr>
-        <p:txBody>
-          <a:bodyPr wrap="square" anchor="t" lIns="0" rIns="0" tIns="0" bIns="0">
-            <a:noAutofit/>
-          </a:bodyPr>
-          <a:lstStyle/>
-          <a:p>
-            <a:pPr algn="l"/>
-            <a:r>
-              <a:rPr sz="1600" b="1" i="0">
-                <a:solidFill>
-                  <a:srgbClr val="6D28D9"/>
-                </a:solidFill>
-                <a:latin typeface="Calibri"/>
-              </a:rPr>
-              <a:t>Best Running Shoes for Beginners</a:t>
-            </a:r>
-          </a:p>
-        </p:txBody>
-      </p:sp>
-      <p:sp>
-        <p:nvSpPr>
-          <p:cNvPr id="20" name="Result snippet"/>
-          <p:cNvSpPr/>
-          <p:nvPr/>
-        </p:nvSpPr>
-        <p:spPr>
-          <a:xfrm>
-            <a:off x="7132320" y="4599431"/>
-            <a:ext cx="2872541" cy="91440"/>
-          </a:xfrm>
-          <a:prstGeom prst="roundRect">
-            <a:avLst>
-              <a:gd name="adj" fmla="val 50000"/>
-            </a:avLst>
-          </a:prstGeom>
-          <a:solidFill>
-            <a:srgbClr val="E5E7EB"/>
-          </a:solidFill>
-          <a:ln>
-            <a:noFill/>
-          </a:ln>
-        </p:spPr>
-        <p:txBody>
-          <a:bodyPr rtlCol="0" anchor="ctr"/>
-          <a:lstStyle/>
-          <a:p>
-            <a:pPr algn="ctr"/>
-          </a:p>
-        </p:txBody>
-      </p:sp>
-      <p:sp>
-        <p:nvSpPr>
-          <p:cNvPr id="21" name="Organic result (SEO) result"/>
-          <p:cNvSpPr/>
-          <p:nvPr/>
-        </p:nvSpPr>
-        <p:spPr>
-          <a:xfrm>
-            <a:off x="6903720" y="5029200"/>
-            <a:ext cx="4419295" cy="1097280"/>
-          </a:xfrm>
-          <a:prstGeom prst="roundRect">
-            <a:avLst>
-              <a:gd name="adj" fmla="val 12500"/>
-            </a:avLst>
-          </a:prstGeom>
-          <a:solidFill>
-            <a:srgbClr val="FFFFFF"/>
-          </a:solidFill>
-          <a:ln w="12700">
-            <a:solidFill>
-              <a:srgbClr val="6D28D9"/>
-            </a:solidFill>
-          </a:ln>
-        </p:spPr>
-        <p:txBody>
-          <a:bodyPr rtlCol="0" anchor="ctr"/>
-          <a:lstStyle/>
-          <a:p>
-            <a:pPr algn="ctr"/>
-          </a:p>
-        </p:txBody>
-      </p:sp>
-      <p:sp>
-        <p:nvSpPr>
-          <p:cNvPr id="22" name="Result source"/>
-          <p:cNvSpPr txBox="1"/>
-          <p:nvPr/>
-        </p:nvSpPr>
-        <p:spPr>
-          <a:xfrm>
-            <a:off x="7132320" y="5166360"/>
-            <a:ext cx="2041855" cy="274320"/>
-          </a:xfrm>
-          <a:prstGeom prst="rect">
-            <a:avLst/>
-          </a:prstGeom>
-          <a:noFill/>
-        </p:spPr>
-        <p:txBody>
-          <a:bodyPr wrap="square" anchor="t" lIns="0" rIns="0" tIns="0" bIns="0">
-            <a:noAutofit/>
-          </a:bodyPr>
-          <a:lstStyle/>
-          <a:p>
-            <a:pPr algn="l"/>
-            <a:r>
-              <a:rPr sz="1200" b="0" i="0">
-                <a:solidFill>
-                  <a:srgbClr val="6B7280"/>
-                </a:solidFill>
-                <a:latin typeface="Calibri"/>
-              </a:rPr>
-              <a:t>stridestore.com</a:t>
-            </a:r>
-          </a:p>
-        </p:txBody>
-      </p:sp>
-      <p:sp>
-        <p:nvSpPr>
-          <p:cNvPr id="23" name="Organic result (SEO) chip"/>
-          <p:cNvSpPr/>
-          <p:nvPr/>
-        </p:nvSpPr>
-        <p:spPr>
-          <a:xfrm>
-            <a:off x="9219895" y="5166360"/>
-            <a:ext cx="1920240" cy="292608"/>
-          </a:xfrm>
-          <a:prstGeom prst="roundRect">
-            <a:avLst>
-              <a:gd name="adj" fmla="val 50000"/>
-            </a:avLst>
-          </a:prstGeom>
-          <a:solidFill>
-            <a:srgbClr val="6D28D9"/>
-          </a:solidFill>
-          <a:ln>
-            <a:noFill/>
-          </a:ln>
-        </p:spPr>
-        <p:txBody>
-          <a:bodyPr rtlCol="0" anchor="ctr"/>
-          <a:lstStyle/>
-          <a:p>
-            <a:pPr algn="ctr"/>
-          </a:p>
-        </p:txBody>
-      </p:sp>
-      <p:sp>
-        <p:nvSpPr>
-          <p:cNvPr id="24" name="Organic result (SEO) label"/>
-          <p:cNvSpPr txBox="1"/>
-          <p:nvPr/>
-        </p:nvSpPr>
-        <p:spPr>
-          <a:xfrm>
-            <a:off x="9219895" y="5166360"/>
-            <a:ext cx="1920240" cy="292608"/>
-          </a:xfrm>
-          <a:prstGeom prst="rect">
-            <a:avLst/>
-          </a:prstGeom>
-          <a:noFill/>
-        </p:spPr>
-        <p:txBody>
-          <a:bodyPr wrap="square" anchor="ctr" lIns="0" rIns="0" tIns="0" bIns="0">
-            <a:noAutofit/>
-          </a:bodyPr>
-          <a:lstStyle/>
-          <a:p>
-            <a:pPr algn="ctr"/>
-            <a:r>
-              <a:rPr sz="1200" b="1" i="0">
-                <a:solidFill>
-                  <a:srgbClr val="FFFFFF"/>
-                </a:solidFill>
-                <a:latin typeface="Calibri"/>
-              </a:rPr>
-              <a:t>Organic result (SEO)</a:t>
-            </a:r>
-          </a:p>
-        </p:txBody>
-      </p:sp>
-      <p:sp>
-        <p:nvSpPr>
-          <p:cNvPr id="25" name="Result headline"/>
-          <p:cNvSpPr txBox="1"/>
-          <p:nvPr/>
-        </p:nvSpPr>
-        <p:spPr>
-          <a:xfrm>
-            <a:off x="7132320" y="5504688"/>
-            <a:ext cx="3962095" cy="320040"/>
-          </a:xfrm>
-          <a:prstGeom prst="rect">
-            <a:avLst/>
-          </a:prstGeom>
-          <a:noFill/>
-        </p:spPr>
-        <p:txBody>
-          <a:bodyPr wrap="square" anchor="t" lIns="0" rIns="0" tIns="0" bIns="0">
-            <a:noAutofit/>
-          </a:bodyPr>
-          <a:lstStyle/>
-          <a:p>
-            <a:pPr algn="l"/>
-            <a:r>
-              <a:rPr sz="1600" b="1" i="0">
-                <a:solidFill>
-                  <a:srgbClr val="6D28D9"/>
-                </a:solidFill>
-                <a:latin typeface="Calibri"/>
-              </a:rPr>
-              <a:t>Running Shoes for Men and Women</a:t>
-            </a:r>
-          </a:p>
-        </p:txBody>
-      </p:sp>
-      <p:sp>
-        <p:nvSpPr>
-          <p:cNvPr id="26" name="Result snippet"/>
+              <a:t>Running Shoes Buying Guide</a:t>
+            </a:r>
+          </a:p>
+        </p:txBody>
+      </p:sp>
+      <p:sp>
+        <p:nvSpPr>
+          <p:cNvPr id="22" name="Result snippet"/>
           <p:cNvSpPr/>
           <p:nvPr/>
         </p:nvSpPr>

</xml_diff>

<commit_message>
Merge the first two SEO points into one
Co-Authored-By: Claude Opus 5.5 <noreply@anthropic.com>
Claude-Session: https://claude.ai/code/session_01CsSUN8PLn8omZWE5zj21pc
</commit_message>
<xml_diff>
--- a/digital-marketing-tools.pptx
+++ b/digital-marketing-tools.pptx
@@ -5472,7 +5472,7 @@
           <a:p>
             <a:pPr marL="274320" indent="-274320">
               <a:spcAft>
-                <a:spcPts val="1800"/>
+                <a:spcPts val="3000"/>
               </a:spcAft>
               <a:buClr>
                 <a:srgbClr val="6D28D9"/>
@@ -5480,19 +5480,19 @@
               <a:buChar char="•"/>
             </a:pPr>
             <a:r>
-              <a:rPr sz="2000" b="0" i="0">
+              <a:rPr sz="2200" b="0" i="0">
                 <a:solidFill>
                   <a:srgbClr val="374151"/>
                 </a:solidFill>
                 <a:latin typeface="Calibri"/>
               </a:rPr>
-              <a:t>SEO is the process of increasing the likelihood that a website appears in search engine results</a:t>
+              <a:t>SEO is the process of increasing the likelihood that a website appears in organic (unpaid) search engine results</a:t>
             </a:r>
           </a:p>
           <a:p>
             <a:pPr marL="274320" indent="-274320">
               <a:spcAft>
-                <a:spcPts val="1800"/>
+                <a:spcPts val="3000"/>
               </a:spcAft>
               <a:buClr>
                 <a:srgbClr val="6D28D9"/>
@@ -5500,19 +5500,28 @@
               <a:buChar char="•"/>
             </a:pPr>
             <a:r>
-              <a:rPr sz="2000" b="0" i="0">
+              <a:rPr sz="2200" b="1" i="0">
+                <a:solidFill>
+                  <a:srgbClr val="1F1B2E"/>
+                </a:solidFill>
+                <a:latin typeface="Calibri"/>
+              </a:rPr>
+              <a:t>Key elements: </a:t>
+            </a:r>
+            <a:r>
+              <a:rPr sz="2200" b="0" i="0">
                 <a:solidFill>
                   <a:srgbClr val="374151"/>
                 </a:solidFill>
                 <a:latin typeface="Calibri"/>
               </a:rPr>
-              <a:t>Helps a website rank higher in organic (unpaid) results</a:t>
+              <a:t>keywords, quality content, fast and mobile-friendly website, backlinks</a:t>
             </a:r>
           </a:p>
           <a:p>
             <a:pPr marL="274320" indent="-274320">
               <a:spcAft>
-                <a:spcPts val="1800"/>
+                <a:spcPts val="3000"/>
               </a:spcAft>
               <a:buClr>
                 <a:srgbClr val="6D28D9"/>
@@ -5520,36 +5529,7 @@
               <a:buChar char="•"/>
             </a:pPr>
             <a:r>
-              <a:rPr sz="2000" b="1" i="0">
-                <a:solidFill>
-                  <a:srgbClr val="1F1B2E"/>
-                </a:solidFill>
-                <a:latin typeface="Calibri"/>
-              </a:rPr>
-              <a:t>Key elements: </a:t>
-            </a:r>
-            <a:r>
-              <a:rPr sz="2000" b="0" i="0">
-                <a:solidFill>
-                  <a:srgbClr val="374151"/>
-                </a:solidFill>
-                <a:latin typeface="Calibri"/>
-              </a:rPr>
-              <a:t>keywords, quality content, fast and mobile-friendly website, backlinks</a:t>
-            </a:r>
-          </a:p>
-          <a:p>
-            <a:pPr marL="274320" indent="-274320">
-              <a:spcAft>
-                <a:spcPts val="1800"/>
-              </a:spcAft>
-              <a:buClr>
-                <a:srgbClr val="6D28D9"/>
-              </a:buClr>
-              <a:buChar char="•"/>
-            </a:pPr>
-            <a:r>
-              <a:rPr sz="2000" b="1" i="0">
+              <a:rPr sz="2200" b="1" i="0">
                 <a:solidFill>
                   <a:srgbClr val="6D28D9"/>
                 </a:solidFill>
@@ -5558,7 +5538,7 @@
               <a:t>Example: </a:t>
             </a:r>
             <a:r>
-              <a:rPr sz="2000" b="0" i="1">
+              <a:rPr sz="2200" b="0" i="1">
                 <a:solidFill>
                   <a:srgbClr val="374151"/>
                 </a:solidFill>

</xml_diff>

<commit_message>
Explain each SEO key element on the slide
Co-Authored-By: Claude Opus 5.5 <noreply@anthropic.com>
Claude-Session: https://claude.ai/code/session_01CsSUN8PLn8omZWE5zj21pc
</commit_message>
<xml_diff>
--- a/digital-marketing-tools.pptx
+++ b/digital-marketing-tools.pptx
@@ -5472,7 +5472,7 @@
           <a:p>
             <a:pPr marL="274320" indent="-274320">
               <a:spcAft>
-                <a:spcPts val="3000"/>
+                <a:spcPts val="1800"/>
               </a:spcAft>
               <a:buClr>
                 <a:srgbClr val="6D28D9"/>
@@ -5480,19 +5480,19 @@
               <a:buChar char="•"/>
             </a:pPr>
             <a:r>
-              <a:rPr sz="2200" b="0" i="0">
+              <a:rPr sz="2000" b="0" i="0">
                 <a:solidFill>
                   <a:srgbClr val="374151"/>
                 </a:solidFill>
                 <a:latin typeface="Calibri"/>
               </a:rPr>
-              <a:t>SEO is the process of increasing the likelihood that a website appears in organic (unpaid) search engine results</a:t>
+              <a:t>SEO is the process of increasing the likelihood that a website appears in organic (unpaid) search engine results, by improving the website's content and structure</a:t>
             </a:r>
           </a:p>
           <a:p>
             <a:pPr marL="274320" indent="-274320">
               <a:spcAft>
-                <a:spcPts val="3000"/>
+                <a:spcPts val="600"/>
               </a:spcAft>
               <a:buClr>
                 <a:srgbClr val="6D28D9"/>
@@ -5500,28 +5500,135 @@
               <a:buChar char="•"/>
             </a:pPr>
             <a:r>
-              <a:rPr sz="2200" b="1" i="0">
+              <a:rPr sz="2000" b="1" i="0">
                 <a:solidFill>
                   <a:srgbClr val="1F1B2E"/>
                 </a:solidFill>
                 <a:latin typeface="Calibri"/>
               </a:rPr>
-              <a:t>Key elements: </a:t>
-            </a:r>
-            <a:r>
-              <a:rPr sz="2200" b="0" i="0">
-                <a:solidFill>
-                  <a:srgbClr val="374151"/>
+              <a:t>Key elements:</a:t>
+            </a:r>
+          </a:p>
+          <a:p>
+            <a:pPr marL="594359" indent="-274320">
+              <a:spcAft>
+                <a:spcPts val="600"/>
+              </a:spcAft>
+              <a:buClr>
+                <a:srgbClr val="6D28D9"/>
+              </a:buClr>
+              <a:buChar char="◦"/>
+            </a:pPr>
+            <a:r>
+              <a:rPr sz="1700" b="1" i="0">
+                <a:solidFill>
+                  <a:srgbClr val="1F1B2E"/>
                 </a:solidFill>
                 <a:latin typeface="Calibri"/>
               </a:rPr>
-              <a:t>keywords, quality content, fast and mobile-friendly website, backlinks</a:t>
+              <a:t>Keywords: </a:t>
+            </a:r>
+            <a:r>
+              <a:rPr sz="1700" b="0" i="0">
+                <a:solidFill>
+                  <a:srgbClr val="374151"/>
+                </a:solidFill>
+                <a:latin typeface="Calibri"/>
+              </a:rPr>
+              <a:t>words people type into search engines</a:t>
+            </a:r>
+          </a:p>
+          <a:p>
+            <a:pPr marL="594359" indent="-274320">
+              <a:spcAft>
+                <a:spcPts val="600"/>
+              </a:spcAft>
+              <a:buClr>
+                <a:srgbClr val="6D28D9"/>
+              </a:buClr>
+              <a:buChar char="◦"/>
+            </a:pPr>
+            <a:r>
+              <a:rPr sz="1700" b="1" i="0">
+                <a:solidFill>
+                  <a:srgbClr val="1F1B2E"/>
+                </a:solidFill>
+                <a:latin typeface="Calibri"/>
+              </a:rPr>
+              <a:t>Quality content: </a:t>
+            </a:r>
+            <a:r>
+              <a:rPr sz="1700" b="0" i="0">
+                <a:solidFill>
+                  <a:srgbClr val="374151"/>
+                </a:solidFill>
+                <a:latin typeface="Calibri"/>
+              </a:rPr>
+              <a:t>useful and relevant information for readers</a:t>
+            </a:r>
+          </a:p>
+          <a:p>
+            <a:pPr marL="594359" indent="-274320">
+              <a:spcAft>
+                <a:spcPts val="600"/>
+              </a:spcAft>
+              <a:buClr>
+                <a:srgbClr val="6D28D9"/>
+              </a:buClr>
+              <a:buChar char="◦"/>
+            </a:pPr>
+            <a:r>
+              <a:rPr sz="1700" b="1" i="0">
+                <a:solidFill>
+                  <a:srgbClr val="1F1B2E"/>
+                </a:solidFill>
+                <a:latin typeface="Calibri"/>
+              </a:rPr>
+              <a:t>Fast, mobile-friendly website: </a:t>
+            </a:r>
+            <a:r>
+              <a:rPr sz="1700" b="0" i="0">
+                <a:solidFill>
+                  <a:srgbClr val="374151"/>
+                </a:solidFill>
+                <a:latin typeface="Calibri"/>
+              </a:rPr>
+              <a:t>loads quickly and is easy to use on phones</a:t>
+            </a:r>
+          </a:p>
+          <a:p>
+            <a:pPr marL="594359" indent="-274320">
+              <a:spcAft>
+                <a:spcPts val="1800"/>
+              </a:spcAft>
+              <a:buClr>
+                <a:srgbClr val="6D28D9"/>
+              </a:buClr>
+              <a:buChar char="◦"/>
+            </a:pPr>
+            <a:r>
+              <a:rPr sz="1700" b="1" i="0">
+                <a:solidFill>
+                  <a:srgbClr val="1F1B2E"/>
+                </a:solidFill>
+                <a:latin typeface="Calibri"/>
+              </a:rPr>
+              <a:t>Backlinks: </a:t>
+            </a:r>
+            <a:r>
+              <a:rPr sz="1700" b="0" i="0">
+                <a:solidFill>
+                  <a:srgbClr val="374151"/>
+                </a:solidFill>
+                <a:latin typeface="Calibri"/>
+              </a:rPr>
+              <a:t>links from other trusted websites</a:t>
             </a:r>
           </a:p>
           <a:p>
             <a:pPr marL="274320" indent="-274320">
               <a:spcAft>
-                <a:spcPts val="3000"/>
+                <a:spcPts val="1800"/>
               </a:spcAft>
               <a:buClr>
                 <a:srgbClr val="6D28D9"/>
@@ -5529,7 +5636,7 @@
               <a:buChar char="•"/>
             </a:pPr>
             <a:r>
-              <a:rPr sz="2200" b="1" i="0">
+              <a:rPr sz="2000" b="1" i="0">
                 <a:solidFill>
                   <a:srgbClr val="6D28D9"/>
                 </a:solidFill>
@@ -5538,7 +5645,7 @@
               <a:t>Example: </a:t>
             </a:r>
             <a:r>
-              <a:rPr sz="2200" b="0" i="1">
+              <a:rPr sz="2000" b="0" i="1">
                 <a:solidFill>
                   <a:srgbClr val="374151"/>
                 </a:solidFill>

</xml_diff>